<commit_message>
Address skill, invention, Marx labour certificates, and reader questions in Prosperity Economics
</commit_message>
<xml_diff>
--- a/Studies/Prosperity-Economics-And-Right-Use/Modern-Economic-Concepts-For-Madhyasth-Darshan-Readers.pptx
+++ b/Studies/Prosperity-Economics-And-Right-Use/Modern-Economic-Concepts-For-Madhyasth-Darshan-Readers.pptx
@@ -756,13 +756,13 @@
           <a:p/>
           <a:p>
             <a:r>
-              <a:t>Aristotle pointed out that real household goods — grain, clothes, tools — have a natural limit set by use, whereas money-making for its own sake has no limit because currency never spoils. Marx formalised this as two circuits: simple exchange (selling a product for money in order to buy another needed product) versus the circuit of capital (investing money to buy labour and materials solely to end up with more money). In his Critique of the Gotha Programme (1875), Marx also argued that a post-capitalist society would first have to pay individuals by labour-time certificates, and could only reach distribution according to need in a distant future stage.</a:t>
+              <a:t>Aristotle pointed out that real household goods — grain, clothes, tools — have a natural limit set by use, whereas money-making for its own sake has no limit because currency never spoils. Marx formalised this as two circuits: simple exchange (selling a product for money in order to buy another needed product) versus the circuit of capital (investing money to buy labour and materials solely to end up with more money). In Capital Vol. I (ch. 1), Marx also held that a commodity's value is set by socially necessary labour time under current average tools, and treated skilled labour as multiplied simple labour based on the training labour embodied in the worker. In his Critique of the Gotha Programme (1875), he argued that a post-capitalist society would first have to pay individuals by labour-time certificates — which he admitted still apply an unequal “bourgeois right” because workers differ in capability and family dependency — and could only reach distribution according to need in a distant future stage.</a:t>
             </a:r>
           </a:p>
           <a:p/>
           <a:p>
             <a:r>
-              <a:t>In relation to Madhyasth Darshan: the treatise likewise shows that real objects cannot be hoarded without spoiling (JV p. 152; MVD p. 183) whereas symbolic currency has no satiation point (AA pp. 5–7, 45). However, Madhyasth Darshan rejects class conflict as the motor of change, and instead of postponing need-based sharing to a distant era, it practices both principles at the same time in different units: sharing according to need inside the family without weighing individual labour, and exchanging at equal labour value between families and villages (AA pp. 1, 119–120).</a:t>
+              <a:t>In relation to Madhyasth Darshan: the treatise likewise shows that real objects cannot be hoarded without spoiling (JV p. 152; MVD p. 183) whereas symbolic currency has no satiation point (AA pp. 5–7, 45). However, rather than deferring need-based sharing to a distant stage or rewarding invention through patent monopolies, Madhyasth Darshan pairs four mechanisms simultaneously across institutions: (1) inside the ten-member family, goods are shared according to need without weighing individual labour or dependency ratios (AA pp. 1, 119–120); (2) between families and villages, labour is evaluated by the fivefold combination of skill (kushalata), proficiency (nipunata), speed of work (karya-gati), time (samay) and means (sadhan) alongside scholarliness (panditya, AA pp. 119, 145); (3) original tools, procedures, methods and formulas (maulikta) are formally recorded and honoured with social prizes (puraskar) as righteous wealth (svadhan, AA pp. 140, 144); and (4) once disseminated openly across the ten tiers, improved tools lower the unit labour value of goods so that society's means of production increase and required labour time decreases (AA pp. 56–58, 118, 145).</a:t>
             </a:r>
           </a:p>
         </p:txBody>
@@ -6637,7 +6637,7 @@
                 </a:solidFill>
                 <a:latin typeface="Cambria"/>
               </a:rPr>
-              <a:t>Capital circuit &amp; two stages (Marx)</a:t>
+              <a:t>Capital, skill &amp; two stages (Marx)</a:t>
             </a:r>
           </a:p>
         </p:txBody>
@@ -6676,7 +6676,7 @@
                 </a:solidFill>
                 <a:latin typeface="Calibri"/>
               </a:rPr>
-              <a:t>Marx contrasted producer exchange (Commodity → Money → Commodity, for use) with capital (Money → Commodity → More Money, M–C–M').</a:t>
+              <a:t>Marx contrasted simple exchange (C → M → C, for use) with capital (M → C → M'). He valued goods by socially necessary labour (skilled = multiplied simple labour).</a:t>
             </a:r>
           </a:p>
           <a:p>
@@ -6695,7 +6695,7 @@
                 </a:solidFill>
                 <a:latin typeface="Calibri"/>
               </a:rPr>
-              <a:t>After capitalism, he proposed two stages: first paying workers in labour-time certificates, and only in a distant future sharing by need.</a:t>
+              <a:t>After capitalism, he split distribution into two stages: labour-time certificates first (still unequal across family needs), and need-sharing only in a distant future.</a:t>
             </a:r>
           </a:p>
         </p:txBody>
@@ -6798,7 +6798,7 @@
                 </a:solidFill>
                 <a:latin typeface="Calibri"/>
               </a:rPr>
-              <a:t>The darshan agrees that symbolic money removes natural limits and labour creates value, but pairs family need-sharing and inter-family labour exchange simultaneously without class war.</a:t>
+              <a:t>Pairs family need-sharing and 5-factor inter-family labour exchange (skill, proficiency, speed, time, means) simultaneously, honouring new tools with prizes (puraskar) and sharing them openly.</a:t>
             </a:r>
           </a:p>
         </p:txBody>
@@ -6837,7 +6837,7 @@
                 </a:solidFill>
                 <a:latin typeface="Calibri"/>
               </a:rPr>
-              <a:t>Part I.2  ·  Study §§2.4, 3.6, 4.1, 4.3, 7.2  ·  Aristotle Politics I  ·  Marx 1867, 1875  ·  AA pp. 1, 5–7, 119–120  ·  4 / 9</a:t>
+              <a:t>Part I.2  ·  Study §§2.4, 3.6, 3.9, 4.1, 4.3, 7.2  ·  Aristotle Politics I  ·  Marx 1867, 1875  ·  AA pp. 1, 119–120, 140, 144–145  ·  4 / 9</a:t>
             </a:r>
           </a:p>
         </p:txBody>

</xml_diff>

<commit_message>
Refine Prosperity Economics services subsection, invention cross-refs, and shram ka vishram
</commit_message>
<xml_diff>
--- a/Studies/Prosperity-Economics-And-Right-Use/Modern-Economic-Concepts-For-Madhyasth-Darshan-Readers.pptx
+++ b/Studies/Prosperity-Economics-And-Right-Use/Modern-Economic-Concepts-For-Madhyasth-Darshan-Readers.pptx
@@ -6837,7 +6837,7 @@
                 </a:solidFill>
                 <a:latin typeface="Calibri"/>
               </a:rPr>
-              <a:t>Part I.2  ·  Study §§2.4, 3.6, 3.9, 4.1, 4.3, 7.2  ·  Aristotle Politics I  ·  Marx 1867, 1875  ·  AA pp. 1, 119–120, 140, 144–145  ·  4 / 9</a:t>
+              <a:t>Part I.2  ·  Study §§2.4, 3.6, 3.10, 4.1, 4.3, 7.2  ·  Aristotle Politics I  ·  Marx 1867, 1875  ·  AA pp. 1, 119–120, 140, 144–145  ·  4 / 9</a:t>
             </a:r>
           </a:p>
         </p:txBody>
@@ -7503,7 +7503,7 @@
                 </a:solidFill>
                 <a:latin typeface="Calibri"/>
               </a:rPr>
-              <a:t>Part I.3  ·  Study §§2.3, 3.8, 4.5, 4.7, 7.2  ·  Veblen 1899  ·  Keynes 1930  ·  Daly 1974  ·  AA pp. 30–33, 114, 142  ·  5 / 9</a:t>
+              <a:t>Part I.3  ·  Study §§2.3, 3.9, 4.5, 4.7, 7.2  ·  Veblen 1899  ·  Keynes 1930  ·  Daly 1974  ·  AA pp. 30–33, 114, 142  ·  5 / 9</a:t>
             </a:r>
           </a:p>
         </p:txBody>
@@ -8169,7 +8169,7 @@
                 </a:solidFill>
                 <a:latin typeface="Calibri"/>
               </a:rPr>
-              <a:t>Part II.1  ·  Study §§3.11, 4.7, 4.9, 8.2–8.3  ·  Polanyi 1944  ·  Hayek 1945  ·  Ostrom 2010  ·  AA pp. 72, 125–138  ·  6 / 9</a:t>
+              <a:t>Part II.1  ·  Study §§3.12, 4.7, 4.9, 8.2–8.3  ·  Polanyi 1944  ·  Hayek 1945  ·  Ostrom 2010  ·  AA pp. 72, 125–138  ·  6 / 9</a:t>
             </a:r>
           </a:p>
         </p:txBody>
@@ -8992,7 +8992,7 @@
                 </a:solidFill>
                 <a:latin typeface="Calibri"/>
               </a:rPr>
-              <a:t>II.3  ·  MONEY &amp; CLEARING  ·  §§2.4, 3.13, 4.8</a:t>
+              <a:t>II.3  ·  MONEY &amp; CLEARING  ·  §§2.4, 3.14, 4.6</a:t>
             </a:r>
           </a:p>
         </p:txBody>
@@ -9463,7 +9463,7 @@
                 </a:solidFill>
                 <a:latin typeface="Calibri"/>
               </a:rPr>
-              <a:t>Part II.3  ·  Study §§2.4, 3.13, 4.8, 8.3–8.4  ·  Stodder 2009  ·  Bank of England 2014  ·  AA pp. 136–138, 142–143  ·  8 / 9</a:t>
+              <a:t>Part II.3  ·  Study §§2.4, 3.14, 4.6, 8.3–8.4  ·  Stodder 2009  ·  Bank of England 2014  ·  AA pp. 136–138, 142–143  ·  8 / 9</a:t>
             </a:r>
           </a:p>
         </p:txBody>

</xml_diff>

<commit_message>
Update Prosperity Economics presentation decks for Earth-scale vision and 10-tier AI backbone
</commit_message>
<xml_diff>
--- a/Studies/Prosperity-Economics-And-Right-Use/Modern-Economic-Concepts-For-Madhyasth-Darshan-Readers.pptx
+++ b/Studies/Prosperity-Economics-And-Right-Use/Modern-Economic-Concepts-For-Madhyasth-Darshan-Readers.pptx
@@ -680,7 +680,7 @@
           <a:p/>
           <a:p>
             <a:r>
-              <a:t>In relation to Madhyasth Darshan: what neoclassical economics treats as a permanent law of human nature (non-satiation) is actually the symptom of deluded jeevan operating in 4.5 activities, where selection and taste run without regulation by contemplation, enlightenment, and realisation (AA pp. 17–18, 95). And pricing by subjective marginal utility severs exchange from objective usefulness value (upyogita mulya) and the value of labour (shram mulya; AA pp. 49, 66).</a:t>
+              <a:t>In relation to Madhyasth Darshan: what neoclassical economics treats as a permanent law of human nature (non-satiation) is actually the symptom of deluded jeevan operating in 4.5 activities, where selection and taste run without regulation by contemplation, enlightenment, and realisation (AA pp. 17–18, 95). Because body-rooted preferences (priya–hita–labha) differ in every body, subjective utility hits Arrow's impossibility barrier and can never reach universal social agreement without realisation (anubhav) in coexistence (AA pp. 19–20, 58–60; MVD p. 203).</a:t>
             </a:r>
           </a:p>
         </p:txBody>
@@ -756,13 +756,13 @@
           <a:p/>
           <a:p>
             <a:r>
-              <a:t>Aristotle pointed out that real household goods — grain, clothes, tools — have a natural limit set by use, whereas money-making for its own sake has no limit because currency never spoils. Marx formalised this as two circuits: simple exchange (selling a product for money in order to buy another needed product) versus the circuit of capital (investing money to buy labour and materials solely to end up with more money). In Capital Vol. I (ch. 1), Marx also held that a commodity's value is set by socially necessary labour time under current average tools, and treated skilled labour as multiplied simple labour based on the training labour embodied in the worker. In his Critique of the Gotha Programme (1875), he argued that a post-capitalist society would first have to pay individuals by labour-time certificates — which he admitted still apply an unequal “bourgeois right” because workers differ in capability and family dependency — and could only reach distribution according to need in a distant future stage.</a:t>
+              <a:t>Aristotle pointed out that real household goods — grain, clothes, tools — have a natural limit set by use, whereas money-making for its own sake has no limit because currency never spoils. Marx formalised this as two circuits: simple exchange (C → M → C, for use) versus the circuit of capital (M → C → M'). In his Critique of the Gotha Programme (1875), he argued that a post-capitalist society would first have to pay individuals by labour-time certificates and could only reach distribution according to need in a distant future stage.</a:t>
             </a:r>
           </a:p>
           <a:p/>
           <a:p>
             <a:r>
-              <a:t>In relation to Madhyasth Darshan: the treatise likewise shows that real objects cannot be hoarded without spoiling (JV p. 152; MVD p. 183) whereas symbolic currency has no satiation point (AA pp. 5–7, 45). However, rather than deferring need-based sharing to a distant stage or rewarding invention through patent monopolies, Madhyasth Darshan pairs four mechanisms simultaneously across institutions: (1) inside the ten-member family, goods are shared according to need without weighing individual labour or dependency ratios (AA pp. 1, 119–120); (2) between families and villages, labour is evaluated by the fivefold combination of skill (kushalata), proficiency (nipunata), speed of work (karya-gati), time (samay) and means (sadhan) alongside scholarliness (panditya, AA pp. 119, 145); (3) original tools, procedures, methods and formulas (maulikta) are formally recorded and honoured with social prizes (puraskar) as righteous wealth (svadhan, AA pp. 140, 144); and (4) once disseminated openly across the ten tiers, improved tools lower the unit labour value of goods so that society's means of production increase and required labour time decreases (AA pp. 56–58, 118, 145).</a:t>
+              <a:t>In relation to Madhyasth Darshan: without jeevan and realisation, post-capitalist models hit both the non-kin sharing barrier and the work-disutility trilemma. By recognising every member as an identical jeevan in a ten-member family and discovering that the restfulness of labour is resolution itself (shram ka vishram = samadhan, AA p. 23), Madhyasth Darshan pairs unconditional need-sharing inside the family (AA pp. 1, 119–120) with five-factor inter-family labour-value exchange (AA pp. 119, 145) and open dissemination of honoured inventions (puraskar, AA pp. 56–58, 140, 144) simultaneously.</a:t>
             </a:r>
           </a:p>
         </p:txBody>
@@ -838,13 +838,13 @@
           <a:p/>
           <a:p>
             <a:r>
-              <a:t>Positional goods are things desired not for bodily nourishment or protection, but to display social rank — what Veblen called conspicuous consumption. As Hirsch noted, if everyone in a crowd stands on tiptoe to see better, no one sees better, yet everyone's feet hurt. Throughput is the ecological economists' term for the total physical stream of minerals, timber, water, and fossil energy pulled out of the earth and returned as heat and waste. A steady-state economy caps that throughput, and a circular economy recycles materials.</a:t>
+              <a:t>Positional goods are things desired not for bodily nourishment or protection, but to display social rank — what Veblen called conspicuous consumption. Throughput is the ecological economists' term for the total physical stream of minerals, timber, water, and fossil energy pulled out of the earth and returned as heat and waste. A steady-state economy caps that throughput, and a circular economy recycles materials.</a:t>
             </a:r>
           </a:p>
           <a:p/>
           <a:p>
             <a:r>
-              <a:t>In relation to Madhyasth Darshan: positional consumption is what happens when a deluded person tries to obtain the established value of respect (samman) through symbolic wealth and sensory display (AA p. 45). And while Madhyasth Darshan fully agrees with keeping extraction within natural regeneration and using cyclical energy (AA pp. 30–33, 142), it shows that material recycling alone cannot hold unless human need itself becomes definite through understanding in the family (§7.2).</a:t>
+              <a:t>In relation to Madhyasth Darshan: positional consumption arises when a deluded jeevan seeks respect (samman) through possessions (AA p. 45). Moreover, external throughput caps and ascetic restraint erode over time if jeevan's inexhaustible powers remain trapped in the 4.5 activities, and mortal body-centric agents discount the distant future. Only awakening the higher 5.5 activities and recognising the continuity of jeevan across bodily journeys closes the human side of the cycle with zero intergenerational discounting (§§4.8, 7.2).</a:t>
             </a:r>
           </a:p>
         </p:txBody>
@@ -920,13 +920,13 @@
           <a:p/>
           <a:p>
             <a:r>
-              <a:t>Friedrich Hayek (1945) pointed out a real coordination problem: knowledge of local soil, weather, equipment, and skills is scattered across millions of households. In a market, rising and falling prices transmit that information automatically, even though prices are distorted by unequal wealth and profiteering. Karl Polanyi (1944) showed that land, human labour, and money were never created to be sold on a market; turning them into commodities disembeds the economy from social relationships. Elinor Ostrom (2010) showed empirically that communities manage shared forests, fisheries, and irrigation best not through privatisation or top-down state control, but through nested, multi-tier local governance.</a:t>
+              <a:t>Friedrich Hayek (1945) pointed out a real coordination problem: knowledge of local soil, weather, equipment, and skills is scattered across millions of households. Karl Polanyi (1944) showed that land, human labour, and money are fictitious commodities whose marketisation destroys society and nature. Elinor Ostrom (2010) showed empirically that communities manage shared resources best through nested, multi-tier local governance.</a:t>
             </a:r>
           </a:p>
           <a:p/>
           <a:p>
             <a:r>
-              <a:t>In relation to Madhyasth Darshan: Ostrom's findings directly support the treatise's ten-tier village-to-world council architecture (AA pp. 27–30, 125–127), and Polanyi's critique matches the darshan's refusal to treat nature, labour, or currency as commodities. Hayek's question explains why passive databases are not enough: when market price speculation is removed, federated AI agents paired with each tier's committees help aggregate local surpluses and deficits so part-time human councils can coordinate without a central bureaucracy (§§8.2–8.3).</a:t>
+              <a:t>In relation to Madhyasth Darshan: scaling polycentric self-governance across ten tiers to the whole Earth while citizens are in the process of realisation (anubhav-gami) and councillors serve part-time (AA p. 127) makes a federated ten-tier AI agentic backbone a structural requirement. Paired AI agents replace speculative price signals and place objective facts and checkable causal logic in common view before every council, so inconsistencies cannot be ignored and the collective self-corrects even when an individual errs (§§8.1–8.3; AA p. 139).</a:t>
             </a:r>
           </a:p>
         </p:txBody>
@@ -6132,7 +6132,7 @@
                 </a:solidFill>
                 <a:latin typeface="Calibri"/>
               </a:rPr>
-              <a:t>Mainstream economics mistakes unguided selection and taste (mun/vritti in delusion) for human nature, and replaces objective usefulness and labour value with subjective price.</a:t>
+              <a:t>Mainstream economics mistakes unguided selection and taste (4.5 activities in delusion) for human nature; without jeevan and realisation in coexistence, subjective utility has no objective anchor.</a:t>
             </a:r>
           </a:p>
         </p:txBody>
@@ -8130,7 +8130,7 @@
                 </a:solidFill>
                 <a:latin typeface="Calibri"/>
               </a:rPr>
-              <a:t>Because cyclical economics removes market price speculation and keeps land, labour and money out of the market, federated AI agents help part-time councils coordinate across 10 tiers.</a:t>
+              <a:t>Removing price speculation across 10 tiers of anubhav-gami humans requires a federated AI agentic backbone that makes facts and checkable logic visible for collective self-correction.</a:t>
             </a:r>
           </a:p>
         </p:txBody>

</xml_diff>

<commit_message>
Add dedicated slides on the 6 deadlocks of current economics and why realisation is needed
</commit_message>
<xml_diff>
--- a/Studies/Prosperity-Economics-And-Right-Use/Modern-Economic-Concepts-For-Madhyasth-Darshan-Readers.pptx
+++ b/Studies/Prosperity-Economics-And-Right-Use/Modern-Economic-Concepts-For-Madhyasth-Darshan-Readers.pptx
@@ -10,6 +10,7 @@
     <p:sldId id="290" r:id="rId42"/>
     <p:sldId id="291" r:id="rId43"/>
     <p:sldId id="292" r:id="rId44"/>
+    <p:sldId id="297" r:id="rId17"/>
     <p:sldId id="293" r:id="rId45"/>
     <p:sldId id="294" r:id="rId46"/>
     <p:sldId id="295" r:id="rId47"/>
@@ -510,13 +511,114 @@
           <a:lstStyle/>
           <a:p>
             <a:r>
-              <a:t>This brief nine-part reference deck accompanies the comparative sections (§§4–8 and §9.6) of Prosperity Economics and Right Use.</a:t>
+              <a:t>This brief ten-part reference deck accompanies the comparative sections (§§4–8 and §9.6) of Prosperity Economics and Right Use.</a:t>
             </a:r>
           </a:p>
           <a:p/>
           <a:p>
             <a:r>
               <a:t>It is designed to be brought up during discussion or Q&amp;A whenever a reader or listener coming from a Madhyasth Darshan background asks what a modern economic term in the comparative tables means, and why we included it in the study.</a:t>
+            </a:r>
+          </a:p>
+        </p:txBody>
+      </p:sp>
+      <p:sp>
+        <p:nvSpPr>
+          <p:cNvPr id="4" name="Slide Number Placeholder 3"/>
+          <p:cNvSpPr>
+            <a:spLocks noGrp="1"/>
+          </p:cNvSpPr>
+          <p:nvPr>
+            <p:ph type="sldNum" idx="5" sz="quarter"/>
+          </p:nvPr>
+        </p:nvSpPr>
+        <p:spPr/>
+      </p:sp>
+    </p:spTree>
+  </p:cSld>
+  <p:clrMapOvr>
+    <a:masterClrMapping/>
+  </p:clrMapOvr>
+</p:notes>
+</file>
+
+<file path=ppt/notesSlides/notesSlide10.xml><?xml version="1.0" encoding="utf-8"?>
+<p:notes xmlns:a="http://schemas.openxmlformats.org/drawingml/2006/main" xmlns:p="http://schemas.openxmlformats.org/presentationml/2006/main" xmlns:r="http://schemas.openxmlformats.org/officeDocument/2006/relationships">
+  <p:cSld>
+    <p:spTree>
+      <p:nvGrpSpPr>
+        <p:cNvPr id="1" name=""/>
+        <p:cNvGrpSpPr/>
+        <p:nvPr/>
+      </p:nvGrpSpPr>
+      <p:grpSpPr>
+        <a:xfrm>
+          <a:off x="0" y="0"/>
+          <a:ext cx="0" cy="0"/>
+          <a:chOff x="0" y="0"/>
+          <a:chExt cx="0" cy="0"/>
+        </a:xfrm>
+      </p:grpSpPr>
+      <p:sp>
+        <p:nvSpPr>
+          <p:cNvPr id="2" name="Slide Image Placeholder 1"/>
+          <p:cNvSpPr>
+            <a:spLocks noGrp="1"/>
+          </p:cNvSpPr>
+          <p:nvPr>
+            <p:ph type="sldImg" idx="2"/>
+          </p:nvPr>
+        </p:nvSpPr>
+        <p:spPr/>
+      </p:sp>
+      <p:sp>
+        <p:nvSpPr>
+          <p:cNvPr id="3" name="Notes Placeholder 2"/>
+          <p:cNvSpPr>
+            <a:spLocks noGrp="1"/>
+          </p:cNvSpPr>
+          <p:nvPr>
+            <p:ph type="body" idx="3" sz="quarter"/>
+          </p:nvPr>
+        </p:nvSpPr>
+        <p:spPr/>
+        <p:txBody>
+          <a:bodyPr/>
+          <a:lstStyle/>
+          <a:p>
+            <a:r>
+              <a:t>This card summarises why existing economic theories — mainstream and heterodox alike — hit six structural deadlocks when they model the human being as a physical-biological body alone, and why jeevan and realisation (anubhav) in coexistence are required to resolve them:</a:t>
+            </a:r>
+          </a:p>
+          <a:p/>
+          <a:p>
+            <a:r>
+              <a:t>1. Rebound vs. ascetic erosion: External caps and moral vows cannot contain jeevan's inexhaustible (akshay, uditodit) powers while the higher 5.5 activities remain unawakened; realisation regulates taste from within (AA pp. 50, 95).</a:t>
+            </a:r>
+          </a:p>
+          <a:p>
+            <a:r>
+              <a:t>2. No observer-invariant social agreement (Arrow 1951): Body-rooted priya–hita–labha preferences differ in every body; realisation in coexistence (trikalabadh satya, AA p. 51; MVD p. 203) provides one shared reality for universal agreement.</a:t>
+            </a:r>
+          </a:p>
+          <a:p>
+            <a:r>
+              <a:t>3. Work-disutility &amp; patent trilemma: Treating work as disutility requires wage fear or monopoly patents; in resolution, labour itself is restful (shram ka vishram = samadhan, AA p. 23) and inventions are honoured with puraskar and shared openly (AA pp. 56–58, 140, 144).</a:t>
+            </a:r>
+          </a:p>
+          <a:p>
+            <a:r>
+              <a:t>4. Non-kin sharing collapse: Recognising every member as a constitutionally identical jeevan enables unconditional need-sharing in the 10-member family and unpaid benevolent service (upkar-pradhan seva, AA pp. 1, 14, 119–120).</a:t>
+            </a:r>
+          </a:p>
+          <a:p>
+            <a:r>
+              <a:t>5. Ledger gaming: Inner sovereignty (samprabhuta) and mutual satisfaction (ubhay-tripti) establish the satiation point of exchange (vinimay ka tripti bindu, AA p. 76).</a:t>
+            </a:r>
+          </a:p>
+          <a:p>
+            <a:r>
+              <a:t>6. Intergenerational discounting: The continuity of jeevan across bodily journeys eliminates discounting of future generations' earth (AA pp. 48, 51, 72, 94).</a:t>
             </a:r>
           </a:p>
         </p:txBody>
@@ -586,7 +688,7 @@
           <a:lstStyle/>
           <a:p>
             <a:r>
-              <a:t>This nine-part reference deck accompanies the comparative sections (§§4–7 and §9.6) of Prosperity Economics and Right Use.</a:t>
+              <a:t>This ten-part reference deck accompanies the comparative sections (§§4–7 and §9.6) of Prosperity Economics and Right Use.</a:t>
             </a:r>
           </a:p>
           <a:p/>
@@ -598,7 +700,7 @@
           <a:p/>
           <a:p>
             <a:r>
-              <a:t>Part I (I.1 to I.3) explains the traditions compared under 'Where Insatiability Comes From', and Part II (II.1 to II.4) explains the six tools under 'What Economics Can Teach'. Each view gives just enough explanation to make the comparison with Madhyasth Darshan clear.</a:t>
+              <a:t>Part I (I.1 to I.4) explains the traditions compared under 'Where Insatiability Comes From', and Part II (II.1 to II.4) explains the six tools under 'What Economics Can Teach'. Each view gives just enough explanation to make the comparison with Madhyasth Darshan clear.</a:t>
             </a:r>
           </a:p>
         </p:txBody>
@@ -4806,7 +4908,673 @@
                 </a:solidFill>
                 <a:latin typeface="Calibri"/>
               </a:rPr>
-              <a:t>For Q&amp;A and discussion  ·  1 / 9</a:t>
+              <a:t>For Q&amp;A and discussion  ·  1 / 10</a:t>
+            </a:r>
+          </a:p>
+        </p:txBody>
+      </p:sp>
+    </p:spTree>
+  </p:cSld>
+  <p:clrMapOvr>
+    <a:masterClrMapping/>
+  </p:clrMapOvr>
+</p:sld>
+</file>
+
+<file path=ppt/slides/slide10.xml><?xml version="1.0" encoding="utf-8"?>
+<p:sld xmlns:a="http://schemas.openxmlformats.org/drawingml/2006/main" xmlns:p="http://schemas.openxmlformats.org/presentationml/2006/main" xmlns:r="http://schemas.openxmlformats.org/officeDocument/2006/relationships">
+  <p:cSld>
+    <p:spTree>
+      <p:nvGrpSpPr>
+        <p:cNvPr id="1" name=""/>
+        <p:cNvGrpSpPr/>
+        <p:nvPr/>
+      </p:nvGrpSpPr>
+      <p:grpSpPr/>
+      <p:sp>
+        <p:nvSpPr>
+          <p:cNvPr id="2" name="Oval 1"/>
+          <p:cNvSpPr/>
+          <p:nvPr/>
+        </p:nvSpPr>
+        <p:spPr>
+          <a:xfrm>
+            <a:off x="457200" y="384048"/>
+            <a:ext cx="365760" cy="365760"/>
+          </a:xfrm>
+          <a:prstGeom prst="ellipse">
+            <a:avLst/>
+          </a:prstGeom>
+          <a:noFill/>
+          <a:ln w="12700">
+            <a:solidFill>
+              <a:srgbClr val="3B4A7A"/>
+            </a:solidFill>
+          </a:ln>
+          <a:effectLst/>
+        </p:spPr>
+        <p:style>
+          <a:lnRef idx="1">
+            <a:schemeClr val="accent1"/>
+          </a:lnRef>
+          <a:fillRef idx="3">
+            <a:schemeClr val="accent1"/>
+          </a:fillRef>
+          <a:effectRef idx="2">
+            <a:schemeClr val="accent1"/>
+          </a:effectRef>
+          <a:fontRef idx="minor">
+            <a:schemeClr val="lt1"/>
+          </a:fontRef>
+        </p:style>
+        <p:txBody>
+          <a:bodyPr rtlCol="0" anchor="ctr">
+            <a:noAutofit/>
+          </a:bodyPr>
+          <a:lstStyle/>
+          <a:p>
+            <a:pPr algn="ctr"/>
+          </a:p>
+        </p:txBody>
+      </p:sp>
+      <p:sp>
+        <p:nvSpPr>
+          <p:cNvPr id="3" name="Oval 2"/>
+          <p:cNvSpPr/>
+          <p:nvPr/>
+        </p:nvSpPr>
+        <p:spPr>
+          <a:xfrm>
+            <a:off x="530352" y="457200"/>
+            <a:ext cx="219456" cy="219456"/>
+          </a:xfrm>
+          <a:prstGeom prst="ellipse">
+            <a:avLst/>
+          </a:prstGeom>
+          <a:noFill/>
+          <a:ln w="12700">
+            <a:solidFill>
+              <a:srgbClr val="3B4A7A"/>
+            </a:solidFill>
+          </a:ln>
+          <a:effectLst/>
+        </p:spPr>
+        <p:style>
+          <a:lnRef idx="1">
+            <a:schemeClr val="accent1"/>
+          </a:lnRef>
+          <a:fillRef idx="3">
+            <a:schemeClr val="accent1"/>
+          </a:fillRef>
+          <a:effectRef idx="2">
+            <a:schemeClr val="accent1"/>
+          </a:effectRef>
+          <a:fontRef idx="minor">
+            <a:schemeClr val="lt1"/>
+          </a:fontRef>
+        </p:style>
+        <p:txBody>
+          <a:bodyPr rtlCol="0" anchor="ctr">
+            <a:noAutofit/>
+          </a:bodyPr>
+          <a:lstStyle/>
+          <a:p>
+            <a:pPr algn="ctr"/>
+          </a:p>
+        </p:txBody>
+      </p:sp>
+      <p:sp>
+        <p:nvSpPr>
+          <p:cNvPr id="4" name="Oval 3"/>
+          <p:cNvSpPr/>
+          <p:nvPr/>
+        </p:nvSpPr>
+        <p:spPr>
+          <a:xfrm>
+            <a:off x="594360" y="521207"/>
+            <a:ext cx="91440" cy="91440"/>
+          </a:xfrm>
+          <a:prstGeom prst="ellipse">
+            <a:avLst/>
+          </a:prstGeom>
+          <a:solidFill>
+            <a:srgbClr val="C9821E"/>
+          </a:solidFill>
+          <a:ln>
+            <a:noFill/>
+          </a:ln>
+          <a:effectLst/>
+        </p:spPr>
+        <p:style>
+          <a:lnRef idx="1">
+            <a:schemeClr val="accent1"/>
+          </a:lnRef>
+          <a:fillRef idx="3">
+            <a:schemeClr val="accent1"/>
+          </a:fillRef>
+          <a:effectRef idx="2">
+            <a:schemeClr val="accent1"/>
+          </a:effectRef>
+          <a:fontRef idx="minor">
+            <a:schemeClr val="lt1"/>
+          </a:fontRef>
+        </p:style>
+        <p:txBody>
+          <a:bodyPr rtlCol="0" anchor="ctr">
+            <a:noAutofit/>
+          </a:bodyPr>
+          <a:lstStyle/>
+          <a:p>
+            <a:pPr algn="ctr"/>
+          </a:p>
+        </p:txBody>
+      </p:sp>
+      <p:sp>
+        <p:nvSpPr>
+          <p:cNvPr id="5" name="TextBox 4"/>
+          <p:cNvSpPr txBox="1"/>
+          <p:nvPr/>
+        </p:nvSpPr>
+        <p:spPr>
+          <a:xfrm>
+            <a:off x="960120" y="256032"/>
+            <a:ext cx="7680960" cy="237744"/>
+          </a:xfrm>
+          <a:prstGeom prst="rect">
+            <a:avLst/>
+          </a:prstGeom>
+          <a:noFill/>
+        </p:spPr>
+        <p:txBody>
+          <a:bodyPr wrap="square" lIns="0" rIns="0" tIns="0" bIns="0" anchor="ctr">
+            <a:noAutofit/>
+          </a:bodyPr>
+          <a:lstStyle/>
+          <a:p>
+            <a:pPr>
+              <a:spcAft>
+                <a:spcPts val="0"/>
+              </a:spcAft>
+            </a:pPr>
+            <a:r>
+              <a:rPr sz="1050" b="1" i="0">
+                <a:solidFill>
+                  <a:srgbClr val="9A6414"/>
+                </a:solidFill>
+                <a:latin typeface="Calibri"/>
+              </a:rPr>
+              <a:t>II.4  ·  LABOUR &amp; RENT ACCOUNTING  ·  §§4.2, 4.10, 8.5</a:t>
+            </a:r>
+          </a:p>
+        </p:txBody>
+      </p:sp>
+      <p:sp>
+        <p:nvSpPr>
+          <p:cNvPr id="6" name="TextBox 5"/>
+          <p:cNvSpPr txBox="1"/>
+          <p:nvPr/>
+        </p:nvSpPr>
+        <p:spPr>
+          <a:xfrm>
+            <a:off x="960120" y="457200"/>
+            <a:ext cx="7726679" cy="566928"/>
+          </a:xfrm>
+          <a:prstGeom prst="rect">
+            <a:avLst/>
+          </a:prstGeom>
+          <a:noFill/>
+        </p:spPr>
+        <p:txBody>
+          <a:bodyPr wrap="square" lIns="0" rIns="0" tIns="0" bIns="0" anchor="ctr">
+            <a:noAutofit/>
+          </a:bodyPr>
+          <a:lstStyle/>
+          <a:p>
+            <a:pPr>
+              <a:spcAft>
+                <a:spcPts val="0"/>
+              </a:spcAft>
+            </a:pPr>
+            <a:r>
+              <a:rPr sz="3000" b="1" i="0">
+                <a:solidFill>
+                  <a:srgbClr val="1E2447"/>
+                </a:solidFill>
+                <a:latin typeface="Cambria"/>
+              </a:rPr>
+              <a:t>Input–Output &amp; Differential Rent</a:t>
+            </a:r>
+          </a:p>
+        </p:txBody>
+      </p:sp>
+      <p:sp>
+        <p:nvSpPr>
+          <p:cNvPr id="7" name="Rounded Rectangle 6"/>
+          <p:cNvSpPr/>
+          <p:nvPr/>
+        </p:nvSpPr>
+        <p:spPr>
+          <a:xfrm>
+            <a:off x="640080" y="1280160"/>
+            <a:ext cx="3840480" cy="2148840"/>
+          </a:xfrm>
+          <a:prstGeom prst="roundRect">
+            <a:avLst>
+              <a:gd name="adj" fmla="val 7000"/>
+            </a:avLst>
+          </a:prstGeom>
+          <a:solidFill>
+            <a:srgbClr val="EEF1F8"/>
+          </a:solidFill>
+          <a:ln>
+            <a:noFill/>
+          </a:ln>
+          <a:effectLst/>
+        </p:spPr>
+        <p:style>
+          <a:lnRef idx="1">
+            <a:schemeClr val="accent1"/>
+          </a:lnRef>
+          <a:fillRef idx="3">
+            <a:schemeClr val="accent1"/>
+          </a:fillRef>
+          <a:effectRef idx="2">
+            <a:schemeClr val="accent1"/>
+          </a:effectRef>
+          <a:fontRef idx="minor">
+            <a:schemeClr val="lt1"/>
+          </a:fontRef>
+        </p:style>
+        <p:txBody>
+          <a:bodyPr rtlCol="0" anchor="ctr">
+            <a:noAutofit/>
+          </a:bodyPr>
+          <a:lstStyle/>
+          <a:p>
+            <a:pPr algn="ctr"/>
+          </a:p>
+        </p:txBody>
+      </p:sp>
+      <p:sp>
+        <p:nvSpPr>
+          <p:cNvPr id="8" name="TextBox 7"/>
+          <p:cNvSpPr txBox="1"/>
+          <p:nvPr/>
+        </p:nvSpPr>
+        <p:spPr>
+          <a:xfrm>
+            <a:off x="822960" y="1399032"/>
+            <a:ext cx="3474720" cy="274320"/>
+          </a:xfrm>
+          <a:prstGeom prst="rect">
+            <a:avLst/>
+          </a:prstGeom>
+          <a:noFill/>
+        </p:spPr>
+        <p:txBody>
+          <a:bodyPr wrap="square" lIns="0" rIns="0" tIns="0" bIns="0" anchor="ctr">
+            <a:noAutofit/>
+          </a:bodyPr>
+          <a:lstStyle/>
+          <a:p>
+            <a:pPr>
+              <a:spcAft>
+                <a:spcPts val="0"/>
+              </a:spcAft>
+            </a:pPr>
+            <a:r>
+              <a:rPr sz="1300" b="1" i="0">
+                <a:solidFill>
+                  <a:srgbClr val="1E2447"/>
+                </a:solidFill>
+                <a:latin typeface="Cambria"/>
+              </a:rPr>
+              <a:t>Input–output &amp; depreciation (Leontief)</a:t>
+            </a:r>
+          </a:p>
+        </p:txBody>
+      </p:sp>
+      <p:sp>
+        <p:nvSpPr>
+          <p:cNvPr id="9" name="TextBox 8"/>
+          <p:cNvSpPr txBox="1"/>
+          <p:nvPr/>
+        </p:nvSpPr>
+        <p:spPr>
+          <a:xfrm>
+            <a:off x="822960" y="1755648"/>
+            <a:ext cx="3474720" cy="1600200"/>
+          </a:xfrm>
+          <a:prstGeom prst="rect">
+            <a:avLst/>
+          </a:prstGeom>
+          <a:noFill/>
+        </p:spPr>
+        <p:txBody>
+          <a:bodyPr wrap="square" lIns="0" rIns="0" tIns="0" bIns="0" anchor="t">
+            <a:noAutofit/>
+          </a:bodyPr>
+          <a:lstStyle/>
+          <a:p>
+            <a:pPr>
+              <a:spcAft>
+                <a:spcPts val="0"/>
+              </a:spcAft>
+            </a:pPr>
+            <a:r>
+              <a:rPr sz="1100" b="0" i="0">
+                <a:solidFill>
+                  <a:srgbClr val="5A6377"/>
+                </a:solidFill>
+                <a:latin typeface="Calibri"/>
+              </a:rPr>
+              <a:t>A loaf of bread requires not only the baker's hours, but also the farmer's grain, the miller's flour, and a small fraction of the oven and plough worn down each season (depreciation).</a:t>
+            </a:r>
+          </a:p>
+          <a:p>
+            <a:pPr>
+              <a:spcBef>
+                <a:spcPts val="600"/>
+              </a:spcBef>
+              <a:spcAft>
+                <a:spcPts val="0"/>
+              </a:spcAft>
+            </a:pPr>
+            <a:r>
+              <a:rPr sz="1100" b="0" i="0">
+                <a:solidFill>
+                  <a:srgbClr val="5A6377"/>
+                </a:solidFill>
+                <a:latin typeface="Calibri"/>
+              </a:rPr>
+              <a:t>An input–output table calculates the total direct and indirect labour across every stage.</a:t>
+            </a:r>
+          </a:p>
+        </p:txBody>
+      </p:sp>
+      <p:sp>
+        <p:nvSpPr>
+          <p:cNvPr id="10" name="Rounded Rectangle 9"/>
+          <p:cNvSpPr/>
+          <p:nvPr/>
+        </p:nvSpPr>
+        <p:spPr>
+          <a:xfrm>
+            <a:off x="4663440" y="1280160"/>
+            <a:ext cx="3840480" cy="2148840"/>
+          </a:xfrm>
+          <a:prstGeom prst="roundRect">
+            <a:avLst>
+              <a:gd name="adj" fmla="val 7000"/>
+            </a:avLst>
+          </a:prstGeom>
+          <a:solidFill>
+            <a:srgbClr val="FAF1DF"/>
+          </a:solidFill>
+          <a:ln>
+            <a:noFill/>
+          </a:ln>
+          <a:effectLst/>
+        </p:spPr>
+        <p:style>
+          <a:lnRef idx="1">
+            <a:schemeClr val="accent1"/>
+          </a:lnRef>
+          <a:fillRef idx="3">
+            <a:schemeClr val="accent1"/>
+          </a:fillRef>
+          <a:effectRef idx="2">
+            <a:schemeClr val="accent1"/>
+          </a:effectRef>
+          <a:fontRef idx="minor">
+            <a:schemeClr val="lt1"/>
+          </a:fontRef>
+        </p:style>
+        <p:txBody>
+          <a:bodyPr rtlCol="0" anchor="ctr">
+            <a:noAutofit/>
+          </a:bodyPr>
+          <a:lstStyle/>
+          <a:p>
+            <a:pPr algn="ctr"/>
+          </a:p>
+        </p:txBody>
+      </p:sp>
+      <p:sp>
+        <p:nvSpPr>
+          <p:cNvPr id="11" name="TextBox 10"/>
+          <p:cNvSpPr txBox="1"/>
+          <p:nvPr/>
+        </p:nvSpPr>
+        <p:spPr>
+          <a:xfrm>
+            <a:off x="4846320" y="1399032"/>
+            <a:ext cx="3474720" cy="274320"/>
+          </a:xfrm>
+          <a:prstGeom prst="rect">
+            <a:avLst/>
+          </a:prstGeom>
+          <a:noFill/>
+        </p:spPr>
+        <p:txBody>
+          <a:bodyPr wrap="square" lIns="0" rIns="0" tIns="0" bIns="0" anchor="ctr">
+            <a:noAutofit/>
+          </a:bodyPr>
+          <a:lstStyle/>
+          <a:p>
+            <a:pPr>
+              <a:spcAft>
+                <a:spcPts val="0"/>
+              </a:spcAft>
+            </a:pPr>
+            <a:r>
+              <a:rPr sz="1300" b="1" i="0">
+                <a:solidFill>
+                  <a:srgbClr val="9A6414"/>
+                </a:solidFill>
+                <a:latin typeface="Cambria"/>
+              </a:rPr>
+              <a:t>Differential rent (Ricardo 1817)</a:t>
+            </a:r>
+          </a:p>
+        </p:txBody>
+      </p:sp>
+      <p:sp>
+        <p:nvSpPr>
+          <p:cNvPr id="12" name="TextBox 11"/>
+          <p:cNvSpPr txBox="1"/>
+          <p:nvPr/>
+        </p:nvSpPr>
+        <p:spPr>
+          <a:xfrm>
+            <a:off x="4846320" y="1755648"/>
+            <a:ext cx="3474720" cy="1600200"/>
+          </a:xfrm>
+          <a:prstGeom prst="rect">
+            <a:avLst/>
+          </a:prstGeom>
+          <a:noFill/>
+        </p:spPr>
+        <p:txBody>
+          <a:bodyPr wrap="square" lIns="0" rIns="0" tIns="0" bIns="0" anchor="t">
+            <a:noAutofit/>
+          </a:bodyPr>
+          <a:lstStyle/>
+          <a:p>
+            <a:pPr>
+              <a:spcAft>
+                <a:spcPts val="0"/>
+              </a:spcAft>
+            </a:pPr>
+            <a:r>
+              <a:rPr sz="1100" b="0" i="0">
+                <a:solidFill>
+                  <a:srgbClr val="5A6377"/>
+                </a:solidFill>
+                <a:latin typeface="Calibri"/>
+              </a:rPr>
+              <a:t>Ten days of equal farming skill and effort may yield 20 quintals of wheat on fertile river-valley soil, but only 10 quintals on stony upland soil.</a:t>
+            </a:r>
+          </a:p>
+          <a:p>
+            <a:pPr>
+              <a:spcBef>
+                <a:spcPts val="600"/>
+              </a:spcBef>
+              <a:spcAft>
+                <a:spcPts val="0"/>
+              </a:spcAft>
+            </a:pPr>
+            <a:r>
+              <a:rPr sz="1100" b="0" i="0">
+                <a:solidFill>
+                  <a:srgbClr val="5A6377"/>
+                </a:solidFill>
+                <a:latin typeface="Calibri"/>
+              </a:rPr>
+              <a:t>Ricardo called the extra 10 quintals differential rent: it comes from nature's fertility, not extra human work.</a:t>
+            </a:r>
+          </a:p>
+        </p:txBody>
+      </p:sp>
+      <p:sp>
+        <p:nvSpPr>
+          <p:cNvPr id="13" name="Rounded Rectangle 12"/>
+          <p:cNvSpPr/>
+          <p:nvPr/>
+        </p:nvSpPr>
+        <p:spPr>
+          <a:xfrm>
+            <a:off x="640080" y="3611880"/>
+            <a:ext cx="7863840" cy="868680"/>
+          </a:xfrm>
+          <a:prstGeom prst="roundRect">
+            <a:avLst>
+              <a:gd name="adj" fmla="val 7000"/>
+            </a:avLst>
+          </a:prstGeom>
+          <a:solidFill>
+            <a:srgbClr val="1E2447"/>
+          </a:solidFill>
+          <a:ln>
+            <a:noFill/>
+          </a:ln>
+          <a:effectLst/>
+        </p:spPr>
+        <p:style>
+          <a:lnRef idx="1">
+            <a:schemeClr val="accent1"/>
+          </a:lnRef>
+          <a:fillRef idx="3">
+            <a:schemeClr val="accent1"/>
+          </a:fillRef>
+          <a:effectRef idx="2">
+            <a:schemeClr val="accent1"/>
+          </a:effectRef>
+          <a:fontRef idx="minor">
+            <a:schemeClr val="lt1"/>
+          </a:fontRef>
+        </p:style>
+        <p:txBody>
+          <a:bodyPr rtlCol="0" anchor="ctr">
+            <a:noAutofit/>
+          </a:bodyPr>
+          <a:lstStyle/>
+          <a:p>
+            <a:pPr algn="ctr"/>
+          </a:p>
+        </p:txBody>
+      </p:sp>
+      <p:sp>
+        <p:nvSpPr>
+          <p:cNvPr id="14" name="TextBox 13"/>
+          <p:cNvSpPr txBox="1"/>
+          <p:nvPr/>
+        </p:nvSpPr>
+        <p:spPr>
+          <a:xfrm>
+            <a:off x="868680" y="3611880"/>
+            <a:ext cx="7406640" cy="868680"/>
+          </a:xfrm>
+          <a:prstGeom prst="rect">
+            <a:avLst/>
+          </a:prstGeom>
+          <a:noFill/>
+        </p:spPr>
+        <p:txBody>
+          <a:bodyPr wrap="square" lIns="0" rIns="0" tIns="0" bIns="0" anchor="ctr">
+            <a:noAutofit/>
+          </a:bodyPr>
+          <a:lstStyle/>
+          <a:p>
+            <a:pPr algn="ctr">
+              <a:spcAft>
+                <a:spcPts val="0"/>
+              </a:spcAft>
+            </a:pPr>
+            <a:r>
+              <a:rPr sz="1350" b="1" i="0">
+                <a:solidFill>
+                  <a:srgbClr val="C9821E"/>
+                </a:solidFill>
+                <a:latin typeface="Cambria"/>
+              </a:rPr>
+              <a:t>Point for Madhyasth Darshan</a:t>
+            </a:r>
+          </a:p>
+          <a:p>
+            <a:pPr algn="ctr">
+              <a:spcAft>
+                <a:spcPts val="0"/>
+              </a:spcAft>
+            </a:pPr>
+            <a:r>
+              <a:rPr sz="1150" b="0" i="0">
+                <a:solidFill>
+                  <a:srgbClr val="FFFFFF"/>
+                </a:solidFill>
+                <a:latin typeface="Calibri"/>
+              </a:rPr>
+              <a:t>To exchange fairly at the value of labour (shram mulya, AA pp. 66, 119–120), committee AI agents use input–output accounting and separate natural abundance from human effort.</a:t>
+            </a:r>
+          </a:p>
+        </p:txBody>
+      </p:sp>
+      <p:sp>
+        <p:nvSpPr>
+          <p:cNvPr id="15" name="TextBox 14"/>
+          <p:cNvSpPr txBox="1"/>
+          <p:nvPr/>
+        </p:nvSpPr>
+        <p:spPr>
+          <a:xfrm>
+            <a:off x="502920" y="4828032"/>
+            <a:ext cx="8138160" cy="256032"/>
+          </a:xfrm>
+          <a:prstGeom prst="rect">
+            <a:avLst/>
+          </a:prstGeom>
+          <a:noFill/>
+        </p:spPr>
+        <p:txBody>
+          <a:bodyPr wrap="square" lIns="0" rIns="0" tIns="0" bIns="0" anchor="ctr">
+            <a:noAutofit/>
+          </a:bodyPr>
+          <a:lstStyle/>
+          <a:p>
+            <a:pPr>
+              <a:spcAft>
+                <a:spcPts val="0"/>
+              </a:spcAft>
+            </a:pPr>
+            <a:r>
+              <a:rPr sz="950" b="0" i="1">
+                <a:solidFill>
+                  <a:srgbClr val="5A6377"/>
+                </a:solidFill>
+                <a:latin typeface="Calibri"/>
+              </a:rPr>
+              <a:t>Part II.4  ·  Study §§3.6, 4.2, 4.10, 8.2, 8.5  ·  Ricardo 1817  ·  Leontief 1936  ·  Cockshott &amp; Cottrell 1993  ·  AA pp. 66, 118–120  ·  10 / 10</a:t>
             </a:r>
           </a:p>
         </p:txBody>
@@ -5199,6 +5967,18 @@
               <a:t>› I.3: Positional goods, throughput &amp; circular loops</a:t>
             </a:r>
           </a:p>
+          <a:p>
+            <a:pPr/>
+            <a:r>
+              <a:rPr sz="1100" b="0" i="0">
+                <a:solidFill>
+                  <a:srgbClr val="5A6377"/>
+                </a:solidFill>
+                <a:latin typeface="Calibri"/>
+              </a:rPr>
+              <a:t>› I.4: Six deadlocks &amp; why realisation is needed</a:t>
+            </a:r>
+          </a:p>
         </p:txBody>
       </p:sp>
       <p:sp>
@@ -5505,7 +6285,7 @@
                 </a:solidFill>
                 <a:latin typeface="Calibri"/>
               </a:rPr>
-              <a:t>Companion to Prosperity Economics and Right Use (§§4–8)  ·  AnalyticMadhyasthDarshan.org  ·  2 / 9</a:t>
+              <a:t>Companion to Prosperity Economics and Right Use (§§4–8)  ·  AnalyticMadhyasthDarshan.org  ·  2 / 10</a:t>
             </a:r>
           </a:p>
         </p:txBody>
@@ -6171,7 +6951,7 @@
                 </a:solidFill>
                 <a:latin typeface="Calibri"/>
               </a:rPr>
-              <a:t>Part I.1  ·  Study §§2.1–2.3, 3.6, 4.4–4.5  ·  Jevons 1871  ·  Robbins 1932  ·  AA pp. 17–18, 49, 66  ·  3 / 9</a:t>
+              <a:t>Part I.1  ·  Study §§2.1–2.3, 3.6, 4.4–4.5  ·  Jevons 1871  ·  Robbins 1932  ·  AA pp. 17–18, 49, 66  ·  3 / 10</a:t>
             </a:r>
           </a:p>
         </p:txBody>
@@ -6837,7 +7617,7 @@
                 </a:solidFill>
                 <a:latin typeface="Calibri"/>
               </a:rPr>
-              <a:t>Part I.2  ·  Study §§2.4, 3.6, 3.10, 4.1, 4.3, 7.2  ·  Aristotle Politics I  ·  Marx 1867, 1875  ·  AA pp. 1, 119–120, 140, 144–145  ·  4 / 9</a:t>
+              <a:t>Part I.2  ·  Study §§2.4, 3.6, 3.10, 4.1, 4.3, 7.2  ·  Aristotle Politics I  ·  Marx 1867, 1875  ·  AA pp. 1, 119–120, 140, 144–145  ·  4 / 10</a:t>
             </a:r>
           </a:p>
         </p:txBody>
@@ -7503,7 +8283,7 @@
                 </a:solidFill>
                 <a:latin typeface="Calibri"/>
               </a:rPr>
-              <a:t>Part I.3  ·  Study §§2.3, 3.9, 4.5, 4.7, 7.2  ·  Veblen 1899  ·  Keynes 1930  ·  Daly 1974  ·  AA pp. 30–33, 114, 142  ·  5 / 9</a:t>
+              <a:t>Part I.3  ·  Study §§2.3, 3.9, 4.5, 4.7, 7.2  ·  Veblen 1899  ·  Keynes 1930  ·  Daly 1974  ·  AA pp. 30–33, 114, 142  ·  5 / 10</a:t>
             </a:r>
           </a:p>
         </p:txBody>
@@ -7521,14 +8301,14 @@
   <p:cSld>
     <p:spTree>
       <p:nvGrpSpPr>
-        <p:cNvPr id="1" name=""/>
+        <p:cNvPr id="2" name=""/>
         <p:cNvGrpSpPr/>
         <p:nvPr/>
       </p:nvGrpSpPr>
       <p:grpSpPr/>
       <p:sp>
         <p:nvSpPr>
-          <p:cNvPr id="2" name="Oval 1"/>
+          <p:cNvPr id="4" name="Oval 1"/>
           <p:cNvSpPr/>
           <p:nvPr/>
         </p:nvSpPr>
@@ -7574,7 +8354,7 @@
       </p:sp>
       <p:sp>
         <p:nvSpPr>
-          <p:cNvPr id="3" name="Oval 2"/>
+          <p:cNvPr id="5" name="Oval 2"/>
           <p:cNvSpPr/>
           <p:nvPr/>
         </p:nvSpPr>
@@ -7620,7 +8400,7 @@
       </p:sp>
       <p:sp>
         <p:nvSpPr>
-          <p:cNvPr id="4" name="Oval 3"/>
+          <p:cNvPr id="6" name="Oval 3"/>
           <p:cNvSpPr/>
           <p:nvPr/>
         </p:nvSpPr>
@@ -7666,7 +8446,7 @@
       </p:sp>
       <p:sp>
         <p:nvSpPr>
-          <p:cNvPr id="5" name="TextBox 4"/>
+          <p:cNvPr id="7" name="TextBox 4"/>
           <p:cNvSpPr txBox="1"/>
           <p:nvPr/>
         </p:nvSpPr>
@@ -7698,14 +8478,14 @@
                 </a:solidFill>
                 <a:latin typeface="Calibri"/>
               </a:rPr>
-              <a:t>II.1  ·  COORDINATION &amp; COMMONS  ·  §§4.7, 4.9, 8.2</a:t>
-            </a:r>
-          </a:p>
-        </p:txBody>
-      </p:sp>
-      <p:sp>
-        <p:nvSpPr>
-          <p:cNvPr id="6" name="TextBox 5"/>
+              <a:t>I.4  ·  STRUCTURAL CEILINGS  ·  §§1.3, 7.2, 9.1</a:t>
+            </a:r>
+          </a:p>
+        </p:txBody>
+      </p:sp>
+      <p:sp>
+        <p:nvSpPr>
+          <p:cNvPr id="8" name="TextBox 5"/>
           <p:cNvSpPr txBox="1"/>
           <p:nvPr/>
         </p:nvSpPr>
@@ -7737,14 +8517,14 @@
                 </a:solidFill>
                 <a:latin typeface="Cambria"/>
               </a:rPr>
-              <a:t>Prices, Non-Commodities &amp; Commons</a:t>
-            </a:r>
-          </a:p>
-        </p:txBody>
-      </p:sp>
-      <p:sp>
-        <p:nvSpPr>
-          <p:cNvPr id="7" name="Rounded Rectangle 6"/>
+              <a:t>Six Deadlocks &amp; Need for Realisation</a:t>
+            </a:r>
+          </a:p>
+        </p:txBody>
+      </p:sp>
+      <p:sp>
+        <p:nvSpPr>
+          <p:cNvPr id="9" name="Rounded Rectangle 6"/>
           <p:cNvSpPr/>
           <p:nvPr/>
         </p:nvSpPr>
@@ -7792,7 +8572,7 @@
       </p:sp>
       <p:sp>
         <p:nvSpPr>
-          <p:cNvPr id="8" name="TextBox 7"/>
+          <p:cNvPr id="10" name="TextBox 7"/>
           <p:cNvSpPr txBox="1"/>
           <p:nvPr/>
         </p:nvSpPr>
@@ -7824,14 +8604,14 @@
                 </a:solidFill>
                 <a:latin typeface="Cambria"/>
               </a:rPr>
-              <a:t>Dispersed knowledge in prices (Hayek)</a:t>
-            </a:r>
-          </a:p>
-        </p:txBody>
-      </p:sp>
-      <p:sp>
-        <p:nvSpPr>
-          <p:cNvPr id="9" name="TextBox 8"/>
+              <a:t>Six deadlocks of body-centric economics</a:t>
+            </a:r>
+          </a:p>
+        </p:txBody>
+      </p:sp>
+      <p:sp>
+        <p:nvSpPr>
+          <p:cNvPr id="11" name="TextBox 8"/>
           <p:cNvSpPr txBox="1"/>
           <p:nvPr/>
         </p:nvSpPr>
@@ -7863,7 +8643,7 @@
                 </a:solidFill>
                 <a:latin typeface="Calibri"/>
               </a:rPr>
-              <a:t>No single central office can know every village's weather, crop yield, tool wear, or local skill.</a:t>
+              <a:t>1. Demand rebound vs. eroding ascetic caps; 2. No observer-invariant social agreement (Arrow); 3. Work-disutility &amp; patent monopoly trap.</a:t>
             </a:r>
           </a:p>
           <a:p>
@@ -7882,14 +8662,14 @@
                 </a:solidFill>
                 <a:latin typeface="Calibri"/>
               </a:rPr>
-              <a:t>Hayek argued that market prices compress all that scattered local knowledge into a single number that tells producers what is scarce — though distorted by profit and wealth.</a:t>
-            </a:r>
-          </a:p>
-        </p:txBody>
-      </p:sp>
-      <p:sp>
-        <p:nvSpPr>
-          <p:cNvPr id="10" name="Rounded Rectangle 9"/>
+              <a:t>4. Non-kin sharing collapse beyond genetic family; 5. Strategic gaming of interest-free ledgers; 6. Mortal discounting of future generations.</a:t>
+            </a:r>
+          </a:p>
+        </p:txBody>
+      </p:sp>
+      <p:sp>
+        <p:nvSpPr>
+          <p:cNvPr id="12" name="Rounded Rectangle 9"/>
           <p:cNvSpPr/>
           <p:nvPr/>
         </p:nvSpPr>
@@ -7937,7 +8717,7 @@
       </p:sp>
       <p:sp>
         <p:nvSpPr>
-          <p:cNvPr id="11" name="TextBox 10"/>
+          <p:cNvPr id="13" name="TextBox 10"/>
           <p:cNvSpPr txBox="1"/>
           <p:nvPr/>
         </p:nvSpPr>
@@ -7969,14 +8749,14 @@
                 </a:solidFill>
                 <a:latin typeface="Cambria"/>
               </a:rPr>
-              <a:t>Fictitious commodities &amp; commons</a:t>
-            </a:r>
-          </a:p>
-        </p:txBody>
-      </p:sp>
-      <p:sp>
-        <p:nvSpPr>
-          <p:cNvPr id="12" name="TextBox 11"/>
+              <a:t>Why realisation (anubhav) is required</a:t>
+            </a:r>
+          </a:p>
+        </p:txBody>
+      </p:sp>
+      <p:sp>
+        <p:nvSpPr>
+          <p:cNvPr id="14" name="TextBox 11"/>
           <p:cNvSpPr txBox="1"/>
           <p:nvPr/>
         </p:nvSpPr>
@@ -8008,7 +8788,7 @@
                 </a:solidFill>
                 <a:latin typeface="Calibri"/>
               </a:rPr>
-              <a:t>Polanyi showed that land (nature), human labour, and money are fictitious commodities: treating them as market goods destroys society and nature.</a:t>
+              <a:t>Realisation in coexistence (trikalabadh satya, MVD p. 203) awakens jeevan's higher 5.5 activities to regulate taste from within and gives one universal anchor for agreement.</a:t>
             </a:r>
           </a:p>
           <a:p>
@@ -8027,14 +8807,14 @@
                 </a:solidFill>
                 <a:latin typeface="Calibri"/>
               </a:rPr>
-              <a:t>Ostrom proved that local communities govern shared forests and water sustainably using nested, multi-tier rules.</a:t>
-            </a:r>
-          </a:p>
-        </p:txBody>
-      </p:sp>
-      <p:sp>
-        <p:nvSpPr>
-          <p:cNvPr id="13" name="Rounded Rectangle 12"/>
+              <a:t>Knowing every person as an identical, continuous jeevan grounds the 10-member family, restful labour (samadhan), exchange satiation (AA p. 76), and 0% discounting.</a:t>
+            </a:r>
+          </a:p>
+        </p:txBody>
+      </p:sp>
+      <p:sp>
+        <p:nvSpPr>
+          <p:cNvPr id="15" name="Rounded Rectangle 12"/>
           <p:cNvSpPr/>
           <p:nvPr/>
         </p:nvSpPr>
@@ -8082,7 +8862,7 @@
       </p:sp>
       <p:sp>
         <p:nvSpPr>
-          <p:cNvPr id="14" name="TextBox 13"/>
+          <p:cNvPr id="16" name="TextBox 13"/>
           <p:cNvSpPr txBox="1"/>
           <p:nvPr/>
         </p:nvSpPr>
@@ -8130,14 +8910,14 @@
                 </a:solidFill>
                 <a:latin typeface="Calibri"/>
               </a:rPr>
-              <a:t>Removing price speculation across 10 tiers of anubhav-gami humans requires a federated AI agentic backbone that makes facts and checkable logic visible for collective self-correction.</a:t>
-            </a:r>
-          </a:p>
-        </p:txBody>
-      </p:sp>
-      <p:sp>
-        <p:nvSpPr>
-          <p:cNvPr id="15" name="TextBox 14"/>
+              <a:t>Neither market prices nor external caps nor moral vows can resolve these 6 deadlocks without jeevan and realisation — and while humans are anubhav-gami, a 10-tier AI backbone is required.</a:t>
+            </a:r>
+          </a:p>
+        </p:txBody>
+      </p:sp>
+      <p:sp>
+        <p:nvSpPr>
+          <p:cNvPr id="17" name="TextBox 14"/>
           <p:cNvSpPr txBox="1"/>
           <p:nvPr/>
         </p:nvSpPr>
@@ -8169,7 +8949,7 @@
                 </a:solidFill>
                 <a:latin typeface="Calibri"/>
               </a:rPr>
-              <a:t>Part II.1  ·  Study §§3.12, 4.7, 4.9, 8.2–8.3  ·  Polanyi 1944  ·  Hayek 1945  ·  Ostrom 2010  ·  AA pp. 72, 125–138  ·  6 / 9</a:t>
+              <a:t>Part I.4  ·  Study §§1.3, 2.1–2.2, 7.2, 8.2, 9.1  ·  AA pp. 18–23, 47–60, 76, 95  ·  MVD p. 203  ·  6 / 10</a:t>
             </a:r>
           </a:p>
         </p:txBody>
@@ -8364,7 +9144,7 @@
                 </a:solidFill>
                 <a:latin typeface="Calibri"/>
               </a:rPr>
-              <a:t>II.2  ·  NEEDS &amp; CAPABILITIES  ·  §§3.4, 4.6, 8.4</a:t>
+              <a:t>II.1  ·  COORDINATION &amp; COMMONS  ·  §§4.7, 4.9, 8.2</a:t>
             </a:r>
           </a:p>
         </p:txBody>
@@ -8403,7 +9183,7 @@
                 </a:solidFill>
                 <a:latin typeface="Cambria"/>
               </a:rPr>
-              <a:t>Objective Needs &amp; Adaptive Preference</a:t>
+              <a:t>Prices, Non-Commodities &amp; Commons</a:t>
             </a:r>
           </a:p>
         </p:txBody>
@@ -8490,7 +9270,7 @@
                 </a:solidFill>
                 <a:latin typeface="Cambria"/>
               </a:rPr>
-              <a:t>Objective needs &amp; capabilities (Sen)</a:t>
+              <a:t>Dispersed knowledge in prices (Hayek)</a:t>
             </a:r>
           </a:p>
         </p:txBody>
@@ -8529,7 +9309,26 @@
                 </a:solidFill>
                 <a:latin typeface="Calibri"/>
               </a:rPr>
-              <a:t>Against market theory (which treats a billionaire's luxury whim and a child's need for milk as equal 'preferences'), Max-Neef, Doyal &amp; Gough, and Sen define objective human needs and capabilities — what people actually need to be nourished, healthy, educated and active.</a:t>
+              <a:t>No single central office can know every village's weather, crop yield, tool wear, or local skill.</a:t>
+            </a:r>
+          </a:p>
+          <a:p>
+            <a:pPr>
+              <a:spcBef>
+                <a:spcPts val="600"/>
+              </a:spcBef>
+              <a:spcAft>
+                <a:spcPts val="0"/>
+              </a:spcAft>
+            </a:pPr>
+            <a:r>
+              <a:rPr sz="1100" b="0" i="0">
+                <a:solidFill>
+                  <a:srgbClr val="5A6377"/>
+                </a:solidFill>
+                <a:latin typeface="Calibri"/>
+              </a:rPr>
+              <a:t>Hayek argued that market prices compress all that scattered local knowledge into a single number that tells producers what is scarce — though distorted by profit and wealth.</a:t>
             </a:r>
           </a:p>
         </p:txBody>
@@ -8616,7 +9415,7 @@
                 </a:solidFill>
                 <a:latin typeface="Cambria"/>
               </a:rPr>
-              <a:t>Adaptive preference (Sen 1999)</a:t>
+              <a:t>Fictitious commodities &amp; commons</a:t>
             </a:r>
           </a:p>
         </p:txBody>
@@ -8655,7 +9454,26 @@
                 </a:solidFill>
                 <a:latin typeface="Calibri"/>
               </a:rPr>
-              <a:t>Subjective desires can be distorted in two opposite ways: luxury advertising inflates artificial wants, while long deprivation makes poor families lower their expectations and accept undernourishment or lack of schooling as normal.</a:t>
+              <a:t>Polanyi showed that land (nature), human labour, and money are fictitious commodities: treating them as market goods destroys society and nature.</a:t>
+            </a:r>
+          </a:p>
+          <a:p>
+            <a:pPr>
+              <a:spcBef>
+                <a:spcPts val="600"/>
+              </a:spcBef>
+              <a:spcAft>
+                <a:spcPts val="0"/>
+              </a:spcAft>
+            </a:pPr>
+            <a:r>
+              <a:rPr sz="1100" b="0" i="0">
+                <a:solidFill>
+                  <a:srgbClr val="5A6377"/>
+                </a:solidFill>
+                <a:latin typeface="Calibri"/>
+              </a:rPr>
+              <a:t>Ostrom proved that local communities govern shared forests and water sustainably using nested, multi-tier rules.</a:t>
             </a:r>
           </a:p>
         </p:txBody>
@@ -8758,7 +9576,7 @@
                 </a:solidFill>
                 <a:latin typeface="Calibri"/>
               </a:rPr>
-              <a:t>Supports the treatise's definite assessment of common and special aspirations in the family (AA p. 112), guided by education-sanskar so need is neither inflated by luxury nor shrunk by deprivation.</a:t>
+              <a:t>Removing price speculation across 10 tiers of anubhav-gami humans requires a federated AI agentic backbone that makes facts and checkable logic visible for collective self-correction.</a:t>
             </a:r>
           </a:p>
         </p:txBody>
@@ -8797,7 +9615,7 @@
                 </a:solidFill>
                 <a:latin typeface="Calibri"/>
               </a:rPr>
-              <a:t>Part II.2  ·  Study §§3.4, 4.6, 8.3–8.4, 9.6  ·  Max-Neef 1991  ·  Doyal &amp; Gough 1991  ·  Sen 1999  ·  AA pp. 26, 112  ·  7 / 9</a:t>
+              <a:t>Part II.1  ·  Study §§3.12, 4.7, 4.9, 8.2–8.3  ·  Polanyi 1944  ·  Hayek 1945  ·  Ostrom 2010  ·  AA pp. 72, 125–138  ·  7 / 10</a:t>
             </a:r>
           </a:p>
         </p:txBody>
@@ -8992,7 +9810,7 @@
                 </a:solidFill>
                 <a:latin typeface="Calibri"/>
               </a:rPr>
-              <a:t>II.3  ·  MONEY &amp; CLEARING  ·  §§2.4, 3.14, 4.6</a:t>
+              <a:t>II.2  ·  NEEDS &amp; CAPABILITIES  ·  §§3.4, 4.6, 8.4</a:t>
             </a:r>
           </a:p>
         </p:txBody>
@@ -9031,7 +9849,7 @@
                 </a:solidFill>
                 <a:latin typeface="Cambria"/>
               </a:rPr>
-              <a:t>Bank Credit vs. Mutual-Credit Clearing</a:t>
+              <a:t>Objective Needs &amp; Adaptive Preference</a:t>
             </a:r>
           </a:p>
         </p:txBody>
@@ -9118,7 +9936,7 @@
                 </a:solidFill>
                 <a:latin typeface="Cambria"/>
               </a:rPr>
-              <a:t>Bank money created as debt (BoE 2014)</a:t>
+              <a:t>Objective needs &amp; capabilities (Sen)</a:t>
             </a:r>
           </a:p>
         </p:txBody>
@@ -9157,26 +9975,7 @@
                 </a:solidFill>
                 <a:latin typeface="Calibri"/>
               </a:rPr>
-              <a:t>In today's economy, most money is not printed by the government or backed by gold.</a:t>
-            </a:r>
-          </a:p>
-          <a:p>
-            <a:pPr>
-              <a:spcBef>
-                <a:spcPts val="600"/>
-              </a:spcBef>
-              <a:spcAft>
-                <a:spcPts val="0"/>
-              </a:spcAft>
-            </a:pPr>
-            <a:r>
-              <a:rPr sz="1100" b="0" i="0">
-                <a:solidFill>
-                  <a:srgbClr val="5A6377"/>
-                </a:solidFill>
-                <a:latin typeface="Calibri"/>
-              </a:rPr>
-              <a:t>As the Bank of England explains, whenever a commercial bank makes a loan, it creates new digital money on its ledger together with an interest-bearing debt.</a:t>
+              <a:t>Against market theory (which treats a billionaire's luxury whim and a child's need for milk as equal 'preferences'), Max-Neef, Doyal &amp; Gough, and Sen define objective human needs and capabilities — what people actually need to be nourished, healthy, educated and active.</a:t>
             </a:r>
           </a:p>
         </p:txBody>
@@ -9263,7 +10062,7 @@
                 </a:solidFill>
                 <a:latin typeface="Cambria"/>
               </a:rPr>
-              <a:t>Mutual-credit clearing (Swiss WIR)</a:t>
+              <a:t>Adaptive preference (Sen 1999)</a:t>
             </a:r>
           </a:p>
         </p:txBody>
@@ -9302,26 +10101,7 @@
                 </a:solidFill>
                 <a:latin typeface="Calibri"/>
               </a:rPr>
-              <a:t>In a mutual-credit clearing network (such as the Swiss WIR cooperative, operating since 1934), producers trade goods using interest-free ledger credits.</a:t>
-            </a:r>
-          </a:p>
-          <a:p>
-            <a:pPr>
-              <a:spcBef>
-                <a:spcPts val="600"/>
-              </a:spcBef>
-              <a:spcAft>
-                <a:spcPts val="0"/>
-              </a:spcAft>
-            </a:pPr>
-            <a:r>
-              <a:rPr sz="1100" b="0" i="0">
-                <a:solidFill>
-                  <a:srgbClr val="5A6377"/>
-                </a:solidFill>
-                <a:latin typeface="Calibri"/>
-              </a:rPr>
-              <a:t>Delivering grain credits your account; taking cloth debits it; across the community the ledger sums to zero.</a:t>
+              <a:t>Subjective desires can be distorted in two opposite ways: luxury advertising inflates artificial wants, while long deprivation makes poor families lower their expectations and accept undernourishment or lack of schooling as normal.</a:t>
             </a:r>
           </a:p>
         </p:txBody>
@@ -9424,7 +10204,7 @@
                 </a:solidFill>
                 <a:latin typeface="Calibri"/>
               </a:rPr>
-              <a:t>Shows practically how the village exchange-reserve (vinimay kosh, AA pp. 136–138, 142–143) can clear production by book accounts without interest, hoarding, or bank debt.</a:t>
+              <a:t>Supports the treatise's definite assessment of common and special aspirations in the family (AA p. 112), guided by education-sanskar so need is neither inflated by luxury nor shrunk by deprivation.</a:t>
             </a:r>
           </a:p>
         </p:txBody>
@@ -9463,7 +10243,7 @@
                 </a:solidFill>
                 <a:latin typeface="Calibri"/>
               </a:rPr>
-              <a:t>Part II.3  ·  Study §§2.4, 3.14, 4.6, 8.3–8.4  ·  Stodder 2009  ·  Bank of England 2014  ·  AA pp. 136–138, 142–143  ·  8 / 9</a:t>
+              <a:t>Part II.2  ·  Study §§3.4, 4.6, 8.3–8.4, 9.6  ·  Max-Neef 1991  ·  Doyal &amp; Gough 1991  ·  Sen 1999  ·  AA pp. 26, 112  ·  8 / 10</a:t>
             </a:r>
           </a:p>
         </p:txBody>
@@ -9658,7 +10438,7 @@
                 </a:solidFill>
                 <a:latin typeface="Calibri"/>
               </a:rPr>
-              <a:t>II.4  ·  LABOUR &amp; RENT ACCOUNTING  ·  §§4.2, 4.10, 8.5</a:t>
+              <a:t>II.3  ·  MONEY &amp; CLEARING  ·  §§2.4, 3.14, 4.6</a:t>
             </a:r>
           </a:p>
         </p:txBody>
@@ -9697,7 +10477,7 @@
                 </a:solidFill>
                 <a:latin typeface="Cambria"/>
               </a:rPr>
-              <a:t>Input–Output &amp; Differential Rent</a:t>
+              <a:t>Bank Credit vs. Mutual-Credit Clearing</a:t>
             </a:r>
           </a:p>
         </p:txBody>
@@ -9784,7 +10564,7 @@
                 </a:solidFill>
                 <a:latin typeface="Cambria"/>
               </a:rPr>
-              <a:t>Input–output &amp; depreciation (Leontief)</a:t>
+              <a:t>Bank money created as debt (BoE 2014)</a:t>
             </a:r>
           </a:p>
         </p:txBody>
@@ -9823,7 +10603,7 @@
                 </a:solidFill>
                 <a:latin typeface="Calibri"/>
               </a:rPr>
-              <a:t>A loaf of bread requires not only the baker's hours, but also the farmer's grain, the miller's flour, and a small fraction of the oven and plough worn down each season (depreciation).</a:t>
+              <a:t>In today's economy, most money is not printed by the government or backed by gold.</a:t>
             </a:r>
           </a:p>
           <a:p>
@@ -9842,7 +10622,7 @@
                 </a:solidFill>
                 <a:latin typeface="Calibri"/>
               </a:rPr>
-              <a:t>An input–output table calculates the total direct and indirect labour across every stage.</a:t>
+              <a:t>As the Bank of England explains, whenever a commercial bank makes a loan, it creates new digital money on its ledger together with an interest-bearing debt.</a:t>
             </a:r>
           </a:p>
         </p:txBody>
@@ -9929,7 +10709,7 @@
                 </a:solidFill>
                 <a:latin typeface="Cambria"/>
               </a:rPr>
-              <a:t>Differential rent (Ricardo 1817)</a:t>
+              <a:t>Mutual-credit clearing (Swiss WIR)</a:t>
             </a:r>
           </a:p>
         </p:txBody>
@@ -9968,7 +10748,7 @@
                 </a:solidFill>
                 <a:latin typeface="Calibri"/>
               </a:rPr>
-              <a:t>Ten days of equal farming skill and effort may yield 20 quintals of wheat on fertile river-valley soil, but only 10 quintals on stony upland soil.</a:t>
+              <a:t>In a mutual-credit clearing network (such as the Swiss WIR cooperative, operating since 1934), producers trade goods using interest-free ledger credits.</a:t>
             </a:r>
           </a:p>
           <a:p>
@@ -9987,7 +10767,7 @@
                 </a:solidFill>
                 <a:latin typeface="Calibri"/>
               </a:rPr>
-              <a:t>Ricardo called the extra 10 quintals differential rent: it comes from nature's fertility, not extra human work.</a:t>
+              <a:t>Delivering grain credits your account; taking cloth debits it; across the community the ledger sums to zero.</a:t>
             </a:r>
           </a:p>
         </p:txBody>
@@ -10090,7 +10870,7 @@
                 </a:solidFill>
                 <a:latin typeface="Calibri"/>
               </a:rPr>
-              <a:t>To exchange fairly at the value of labour (shram mulya, AA pp. 66, 119–120), committee AI agents use input–output accounting and separate natural abundance from human effort.</a:t>
+              <a:t>Shows practically how the village exchange-reserve (vinimay kosh, AA pp. 136–138, 142–143) can clear production by book accounts without interest, hoarding, or bank debt.</a:t>
             </a:r>
           </a:p>
         </p:txBody>
@@ -10129,7 +10909,7 @@
                 </a:solidFill>
                 <a:latin typeface="Calibri"/>
               </a:rPr>
-              <a:t>Part II.4  ·  Study §§3.6, 4.2, 4.10, 8.2, 8.5  ·  Ricardo 1817  ·  Leontief 1936  ·  Cockshott &amp; Cottrell 1993  ·  AA pp. 66, 118–120  ·  9 / 9</a:t>
+              <a:t>Part II.3  ·  Study §§2.4, 3.14, 4.6, 8.3–8.4  ·  Stodder 2009  ·  Bank of England 2014  ·  AA pp. 136–138, 142–143  ·  9 / 10</a:t>
             </a:r>
           </a:p>
         </p:txBody>

</xml_diff>

<commit_message>
Clarify jeevan realisation in satta and nature as a whole across study and decks
</commit_message>
<xml_diff>
--- a/Studies/Prosperity-Economics-And-Right-Use/Modern-Economic-Concepts-For-Madhyasth-Darshan-Readers.pptx
+++ b/Studies/Prosperity-Economics-And-Right-Use/Modern-Economic-Concepts-For-Madhyasth-Darshan-Readers.pptx
@@ -598,7 +598,7 @@
           </a:p>
           <a:p>
             <a:r>
-              <a:t>2. No observer-invariant social agreement (Arrow 1951): Body-rooted priya–hita–labha preferences differ in every body; realisation in coexistence (trikalabadh satya, AA p. 51; MVD p. 203) provides one shared reality for universal agreement.</a:t>
+              <a:t>2. No observer-invariant social agreement (Arrow 1951): Body-rooted priya–hita–labha preferences differ in every body; every human is jeevan with the ability to realise in the coexistence of satta (vyapak) and nature as a whole at once (trikalabadh satya, AA pp. 47, 51; MVD p. 203), providing one shared reality for universal agreement.</a:t>
             </a:r>
           </a:p>
           <a:p>
@@ -608,7 +608,7 @@
           </a:p>
           <a:p>
             <a:r>
-              <a:t>4. Non-kin sharing collapse: Recognising every member as a constitutionally identical jeevan enables unconditional need-sharing in the 10-member family and unpaid benevolent service (upkar-pradhan seva, AA pp. 1, 14, 119–120).</a:t>
+              <a:t>4. Non-kin sharing collapse: Because every member is jeevan with the ability to realise in the coexistence of satta (vyapak) and nature as a whole at once, this forms the basis of unconditional need-sharing in the 10-member family and unpaid benevolent service (upkar-pradhan seva, AA pp. 1, 14, 119–120).</a:t>
             </a:r>
           </a:p>
           <a:p>
@@ -864,7 +864,7 @@
           <a:p/>
           <a:p>
             <a:r>
-              <a:t>In relation to Madhyasth Darshan: without jeevan and realisation, post-capitalist models hit both the non-kin sharing barrier and the work-disutility trilemma. By recognising every member as an identical jeevan in a ten-member family and discovering that the restfulness of labour is resolution itself (shram ka vishram = samadhan, AA p. 23), Madhyasth Darshan pairs unconditional need-sharing inside the family (AA pp. 1, 119–120) with five-factor inter-family labour-value exchange (AA pp. 119, 145) and open dissemination of honoured inventions (puraskar, AA pp. 56–58, 140, 144) simultaneously.</a:t>
+              <a:t>In relation to Madhyasth Darshan: without jeevan and realisation, post-capitalist models hit both the non-kin sharing barrier and the work-disutility trilemma. By because every member is jeevan, able to realise in the coexistence of satta (vyapak) and nature as a whole at once, forming the basis of the ten-member family and discovering that the restfulness of labour is resolution itself (shram ka vishram = samadhan, AA p. 23), Madhyasth Darshan pairs unconditional need-sharing inside the family (AA pp. 1, 119–120) with five-factor inter-family labour-value exchange (AA pp. 119, 145) and open dissemination of honoured inventions (puraskar, AA pp. 56–58, 140, 144) simultaneously.</a:t>
             </a:r>
           </a:p>
         </p:txBody>
@@ -8788,7 +8788,7 @@
                 </a:solidFill>
                 <a:latin typeface="Calibri"/>
               </a:rPr>
-              <a:t>Realisation in coexistence (trikalabadh satya, MVD p. 203) awakens jeevan's higher 5.5 activities to regulate taste from within and gives one universal anchor for agreement.</a:t>
+              <a:t>Realisation in the coexistence of satta (vyapak) and nature as a whole at once (MVD p. 203) awakens jeevan's higher 5.5 activities to regulate taste and gives one universal anchor.</a:t>
             </a:r>
           </a:p>
           <a:p>
@@ -8807,7 +8807,7 @@
                 </a:solidFill>
                 <a:latin typeface="Calibri"/>
               </a:rPr>
-              <a:t>Knowing every person as an identical, continuous jeevan grounds the 10-member family, restful labour (samadhan), exchange satiation (AA p. 76), and 0% discounting.</a:t>
+              <a:t>Every member is jeevan with this capacity to realise the whole — the basis for the 10-member family, restful labour (samadhan), exchange satiation (AA p. 76), and 0% discounting.</a:t>
             </a:r>
           </a:p>
         </p:txBody>

</xml_diff>

<commit_message>
Clarify intergenerational ecology via prosperity in the whole and human perpetuity
</commit_message>
<xml_diff>
--- a/Studies/Prosperity-Economics-And-Right-Use/Modern-Economic-Concepts-For-Madhyasth-Darshan-Readers.pptx
+++ b/Studies/Prosperity-Economics-And-Right-Use/Modern-Economic-Concepts-For-Madhyasth-Darshan-Readers.pptx
@@ -618,7 +618,7 @@
           </a:p>
           <a:p>
             <a:r>
-              <a:t>6. Intergenerational discounting: The continuity of jeevan across bodily journeys eliminates discounting of future generations' earth (AA pp. 48, 51, 72, 94).</a:t>
+              <a:t>6. Intergenerational discounting: A realised human sees the prosperity of oneself and one's family in the prosperity of the whole and the perpetuity of human civilization across generations (AA pp. 62–63, 72, 94, 142, 146; KD p. 7), eliminating intergenerational discounting.</a:t>
             </a:r>
           </a:p>
         </p:txBody>
@@ -946,7 +946,7 @@
           <a:p/>
           <a:p>
             <a:r>
-              <a:t>In relation to Madhyasth Darshan: positional consumption arises when a deluded jeevan seeks respect (samman) through possessions (AA p. 45). Moreover, external throughput caps and ascetic restraint erode over time if jeevan's inexhaustible powers remain trapped in the 4.5 activities, and mortal body-centric agents discount the distant future. Only awakening the higher 5.5 activities and recognising the continuity of jeevan across bodily journeys closes the human side of the cycle with zero intergenerational discounting (§§4.8, 7.2).</a:t>
+              <a:t>In relation to Madhyasth Darshan: positional consumption arises when a deluded jeevan seeks respect (samman) through possessions (AA p. 45). Moreover, external throughput caps and ascetic restraint erode over time if jeevan's inexhaustible powers remain trapped in the 4.5 activities, and agents seeking private prosperity apart from the whole discount the distant future. Only awakening the higher 5.5 activities and seeing one's own and one's family's prosperity in the prosperity of the whole and the perpetuity of human civilization closes the human side of the cycle with zero intergenerational discounting (§§4.7, 7.2).</a:t>
             </a:r>
           </a:p>
         </p:txBody>
@@ -8662,7 +8662,7 @@
                 </a:solidFill>
                 <a:latin typeface="Calibri"/>
               </a:rPr>
-              <a:t>4. Non-kin sharing collapse beyond genetic family; 5. Strategic gaming of interest-free ledgers; 6. Mortal discounting of future generations.</a:t>
+              <a:t>4. Non-kin sharing collapse beyond genetic family; 5. Strategic gaming of interest-free ledgers; 6. Discounting future generations for private gain.</a:t>
             </a:r>
           </a:p>
         </p:txBody>
@@ -8807,7 +8807,7 @@
                 </a:solidFill>
                 <a:latin typeface="Calibri"/>
               </a:rPr>
-              <a:t>Every member is jeevan with this capacity to realise the whole — the basis for the 10-member family, restful labour (samadhan), exchange satiation (AA p. 76), and 0% discounting.</a:t>
+              <a:t>Every member is jeevan, able to realise the whole — grounding the 10-member family, restful labour, exchange satiation, and seeing own/family prosperity in the whole and human perpetuity.</a:t>
             </a:r>
           </a:p>
         </p:txBody>

</xml_diff>

<commit_message>
Refine Prosperity Economics and Right Use flow, prose, and companion decks
</commit_message>
<xml_diff>
--- a/Studies/Prosperity-Economics-And-Right-Use/Modern-Economic-Concepts-For-Madhyasth-Darshan-Readers.pptx
+++ b/Studies/Prosperity-Economics-And-Right-Use/Modern-Economic-Concepts-For-Madhyasth-Darshan-Readers.pptx
@@ -587,7 +587,7 @@
           <a:lstStyle/>
           <a:p>
             <a:r>
-              <a:t>This card summarises why existing economic theories — mainstream and heterodox alike — hit six structural deadlocks when they model the human being as a physical-biological body alone, and why jeevan and realisation (anubhav) in coexistence are required to resolve them:</a:t>
+              <a:t>This card summarises why existing economic theories — mainstream and heterodox alike — hit six structural deadlocks when they model the human being as a physical-biological body alone, falling short of an undivided society (akhand samaj) and universal orderliness (sarvabhaum vyavastha), and why jeevan and the realisation (anubhav) of coexistence are required to resolve them:</a:t>
             </a:r>
           </a:p>
           <a:p/>
@@ -598,17 +598,17 @@
           </a:p>
           <a:p>
             <a:r>
-              <a:t>2. No observer-invariant social agreement (Arrow 1951): Body-rooted priya–hit–labh preferences differ in every body; every human is jeevan with the ability to realise in the coexistence of satta (vyapak) and nature as a whole at once (trikalabadh satya, AA pp. 47, 51; MVD p. 203), providing one shared reality for universal agreement.</a:t>
-            </a:r>
-          </a:p>
-          <a:p>
-            <a:r>
-              <a:t>3. Work-disutility &amp; patent trilemma: Treating work as disutility requires wage fear or monopoly patents; in resolution, labour itself is restful (shram ka vishram = samadhan, AA p. 23) and inventions are honoured with puraskar and shared openly (AA pp. 56–58, 140, 144).</a:t>
-            </a:r>
-          </a:p>
-          <a:p>
-            <a:r>
-              <a:t>4. Non-kin sharing collapse: Because every member is jeevan with the ability to realise in the coexistence of satta (vyapak) and nature as a whole at once, this forms the basis of unconditional need-sharing in the 10-member family and unpaid benevolent service (upkar-pradhan seva, AA pp. 1, 14, 119–120).</a:t>
+              <a:t>2. No observer-invariant social agreement (Arrow 1951): Body-rooted priya–hit–labh preferences differ in every body; every human is jeevan with the ability to realise the coexistence of satta (vyapak) and nature as a whole at once (trikalabadh satya, AA pp. 47, 51; MVD p. 203), providing one shared reality for universal agreement.</a:t>
+            </a:r>
+          </a:p>
+          <a:p>
+            <a:r>
+              <a:t>3. Work-disutility &amp; patent trilemma: Treating work as disutility requires wage fear or monopoly patents; in resolution, labour finds its restfulness (shram ka vishram in samadhan, AA p. 23) and inventions are honoured with puraskar and shared openly (AA pp. 56–58, 140, 144).</a:t>
+            </a:r>
+          </a:p>
+          <a:p>
+            <a:r>
+              <a:t>4. Non-kin sharing collapse: Because every member is jeevan with the ability to realise the coexistence of satta (vyapak) and nature as a whole at once, this forms the basis of unconditional need-sharing in the 10-member family and unpaid benevolent service (upkar-pradhan seva, AA pp. 1, 14, 119–120).</a:t>
             </a:r>
           </a:p>
           <a:p>
@@ -782,7 +782,7 @@
           <a:p/>
           <a:p>
             <a:r>
-              <a:t>In relation to Madhyasth Darshan: what neoclassical economics treats as a permanent law of human nature (non-satiation) is actually the symptom of deluded jeevan operating in 4.5 activities, where selection and taste run without regulation by contemplation, enlightenment, and realisation (AA pp. 17–18, 95). Because body-rooted preferences (priya–hita–labha) differ in every body, subjective utility hits Arrow's impossibility barrier and can never reach universal social agreement without realisation (anubhav) in coexistence (AA pp. 19–20, 58–60; MVD p. 203).</a:t>
+              <a:t>In relation to Madhyasth Darshan: what neoclassical economics treats as a permanent law of human nature (non-satiation) is actually the symptom of deluded jeevan operating in 4.5 activities, where selection and taste run without regulation by contemplation, enlightenment, and realisation (AA pp. 17–18, 95). Because body-rooted preferences (priya–hit–labh) differ in every body, subjective utility hits Arrow's impossibility barrier and can never reach universal social agreement without the realisation (anubhav) of coexistence (AA pp. 19–20, 58–60; MVD p. 203).</a:t>
             </a:r>
           </a:p>
         </p:txBody>
@@ -864,7 +864,7 @@
           <a:p/>
           <a:p>
             <a:r>
-              <a:t>In relation to Madhyasth Darshan: without jeevan and realisation, post-capitalist models hit both the non-kin sharing barrier and the work-disutility trilemma. By because every member is jeevan, able to realise in the coexistence of satta (vyapak) and nature as a whole at once, forming the basis of the ten-member family and discovering that the restfulness of labour is resolution itself (shram ka vishram = samadhan, AA p. 23), Madhyasth Darshan pairs unconditional need-sharing inside the family (AA pp. 1, 119–120) with five-factor inter-family labour-value exchange (AA pp. 119, 145) and open dissemination of honoured inventions (puraskar, AA pp. 56–58, 140, 144) simultaneously.</a:t>
+              <a:t>In relation to Madhyasth Darshan: without jeevan and realisation, post-capitalist models hit both the non-kin sharing barrier and the work-disutility trilemma. Because every member is jeevan, able to realise the coexistence of satta (vyapak) and nature as a whole at once, forming the basis of the ten-member family and discovering that labour finds its restfulness in resolution (shram ka vishram in samadhan, AA p. 23), Madhyasth Darshan pairs unconditional need-sharing inside the family (AA pp. 1, 119–120) with five-factor inter-family labour-value exchange (AA pp. 119, 145) and open dissemination of honoured inventions (puraskar, AA pp. 56–58, 140, 144) simultaneously.</a:t>
             </a:r>
           </a:p>
         </p:txBody>
@@ -1028,7 +1028,7 @@
           <a:p/>
           <a:p>
             <a:r>
-              <a:t>In relation to Madhyasth Darshan: scaling polycentric self-governance across ten tiers to the whole Earth while citizens are in the process of realisation (anubhav-gami) and councillors serve part-time (AA p. 127) makes a federated ten-tier AI agentic backbone a structural requirement. Paired AI agents replace speculative price signals and place objective facts and checkable causal logic in common view before every council, so inconsistencies cannot be ignored and the collective self-corrects even when an individual errs (§§8.1–8.3; AA p. 139).</a:t>
+              <a:t>In relation to Madhyasth Darshan: scaling polycentric self-governance across ten tiers while citizens are in the process of realisation (anubhav-gami) and councillors serve part-time (AA p. 127) can be assisted by a federated ten-tier AI agentic framework as a practical coordination tool. Paired AI agents help aggregate surpluses and deficits without speculative price signals and place clear facts before councils so errors can be examined and corrected (§§8.1–8.3; AA p. 139).</a:t>
             </a:r>
           </a:p>
         </p:txBody>
@@ -6912,7 +6912,7 @@
                 </a:solidFill>
                 <a:latin typeface="Calibri"/>
               </a:rPr>
-              <a:t>Mainstream economics mistakes unguided selection and taste (4.5 activities in delusion) for human nature; without jeevan and realisation in coexistence, subjective utility has no objective anchor.</a:t>
+              <a:t>Mainstream economics mistakes unguided selection and taste (4.5 activities in delusion) for human nature; without jeevan and the realisation of coexistence, subjective utility has no objective anchor.</a:t>
             </a:r>
           </a:p>
         </p:txBody>
@@ -7456,7 +7456,7 @@
                 </a:solidFill>
                 <a:latin typeface="Calibri"/>
               </a:rPr>
-              <a:t>Marx contrasted simple exchange (C → M → C, for use) with capital (M → C → M'). He valued goods by socially necessary labour (skilled = multiplied simple labour).</a:t>
+              <a:t>Marx contrasted simple exchange (C → M → C, for use) with capital (M → C → M'). He valued goods by socially necessary labour (skilled as multiplied simple labour).</a:t>
             </a:r>
           </a:p>
           <a:p>
@@ -8788,7 +8788,7 @@
                 </a:solidFill>
                 <a:latin typeface="Calibri"/>
               </a:rPr>
-              <a:t>Realisation in the coexistence of satta (vyapak) and nature as a whole at once (MVD p. 203) awakens jeevan's higher 5.5 activities to regulate taste and gives one universal anchor.</a:t>
+              <a:t>Realisation of the coexistence of satta (vyapak) and nature as a whole at once (MVD p. 203) awakens jeevan's higher 5.5 activities to regulate taste and gives one universal anchor.</a:t>
             </a:r>
           </a:p>
           <a:p>
@@ -8910,7 +8910,7 @@
                 </a:solidFill>
                 <a:latin typeface="Calibri"/>
               </a:rPr>
-              <a:t>Neither market prices nor external caps nor moral vows can resolve these 6 deadlocks without jeevan and realisation — and while humans are anubhav-gami, a 10-tier AI backbone is required.</a:t>
+              <a:t>Neither market prices nor external caps nor moral vows can resolve these 6 deadlocks — prevailing economic methods cannot achieve akhand samaj and sarvabhaum vyavastha without jeevan and realisation.</a:t>
             </a:r>
           </a:p>
         </p:txBody>
@@ -9576,7 +9576,7 @@
                 </a:solidFill>
                 <a:latin typeface="Calibri"/>
               </a:rPr>
-              <a:t>Removing price speculation across 10 tiers of anubhav-gami humans requires a federated AI agentic backbone that makes facts and checkable logic visible for collective self-correction.</a:t>
+              <a:t>Federated AI agents can serve as a practical coordination tool across 10 tiers, aggregating surpluses and deficits without speculative prices while human councils judge.</a:t>
             </a:r>
           </a:p>
         </p:txBody>

</xml_diff>